<commit_message>
deck: fix slide-4 text overflow found by the fit check
</commit_message>
<xml_diff>
--- a/deck/ShramShield-HACKDAY-1.0.pptx
+++ b/deck/ShramShield-HACKDAY-1.0.pptx
@@ -4741,8 +4741,8 @@
         </p:nvSpPr>
         <p:spPr>
           <a:xfrm>
-            <a:off x="640080" y="3840480"/>
-            <a:ext cx="10972800" cy="914400"/>
+            <a:off x="640080" y="3794760"/>
+            <a:ext cx="10972800" cy="1143000"/>
           </a:xfrm>
           <a:prstGeom prst="rect">
             <a:avLst/>
@@ -4796,8 +4796,8 @@
         </p:nvSpPr>
         <p:spPr>
           <a:xfrm>
-            <a:off x="640080" y="4937760"/>
-            <a:ext cx="5212080" cy="1371600"/>
+            <a:off x="640080" y="5029200"/>
+            <a:ext cx="5212080" cy="1325880"/>
           </a:xfrm>
           <a:prstGeom prst="rect">
             <a:avLst/>
@@ -4842,8 +4842,8 @@
         </p:nvSpPr>
         <p:spPr>
           <a:xfrm>
-            <a:off x="914400" y="5120640"/>
-            <a:ext cx="4754880" cy="1097280"/>
+            <a:off x="914400" y="5193792"/>
+            <a:ext cx="4754880" cy="1051560"/>
           </a:xfrm>
           <a:prstGeom prst="rect">
             <a:avLst/>
@@ -4897,8 +4897,8 @@
         </p:nvSpPr>
         <p:spPr>
           <a:xfrm>
-            <a:off x="6309360" y="4937760"/>
-            <a:ext cx="5212080" cy="1371600"/>
+            <a:off x="6309360" y="5029200"/>
+            <a:ext cx="5212080" cy="1325880"/>
           </a:xfrm>
           <a:prstGeom prst="rect">
             <a:avLst/>
@@ -4943,8 +4943,8 @@
         </p:nvSpPr>
         <p:spPr>
           <a:xfrm>
-            <a:off x="6583680" y="5120640"/>
-            <a:ext cx="4754880" cy="1097280"/>
+            <a:off x="6583680" y="5193792"/>
+            <a:ext cx="4754880" cy="1051560"/>
           </a:xfrm>
           <a:prstGeom prst="rect">
             <a:avLst/>

</xml_diff>

<commit_message>
deck: sync to the audited artifact — 69/69 tests, copy-plan hand-off row, metric basis stated
</commit_message>
<xml_diff>
--- a/deck/ShramShield-HACKDAY-1.0.pptx
+++ b/deck/ShramShield-HACKDAY-1.0.pptx
@@ -3881,7 +3881,7 @@
         </p:nvGraphicFramePr>
         <p:xfrm>
           <a:off x="640080" y="1828800"/>
-          <a:ext cx="10881359" cy="2084832"/>
+          <a:ext cx="10881359" cy="2432304"/>
         </p:xfrm>
         <a:graphic>
           <a:graphicData uri="http://schemas.openxmlformats.org/drawingml/2006/table">
@@ -3998,7 +3998,7 @@
                           </a:solidFill>
                           <a:latin typeface="Helvetica Neue"/>
                         </a:rPr>
-                        <a:t>Minutes above the safe limit</a:t>
+                        <a:t>Minutes above the limit (8 h window)</a:t>
                       </a:r>
                     </a:p>
                   </a:txBody>
@@ -4020,7 +4020,7 @@
                           </a:solidFill>
                           <a:latin typeface="Helvetica Neue"/>
                         </a:rPr>
-                        <a:t>60 min at 05:00 vs 240 min at 09:00</a:t>
+                        <a:t>60 min at 05:00 vs 240 min on the 09:00 rota</a:t>
                       </a:r>
                     </a:p>
                   </a:txBody>
@@ -4158,7 +4158,53 @@
                           </a:solidFill>
                           <a:latin typeface="Helvetica Neue"/>
                         </a:rPr>
-                        <a:t>listed explicitly, e.g. 11:00, 12:00, 13:00, 14:00 for very heavy work</a:t>
+                        <a:t>11:00–14:00 for very heavy work on a real May 2025 Delhi day</a:t>
+                      </a:r>
+                    </a:p>
+                  </a:txBody>
+                  <a:tcPr>
+                    <a:solidFill>
+                      <a:srgbClr val="17202B"/>
+                    </a:solidFill>
+                  </a:tcPr>
+                </a:tc>
+              </a:tr>
+              <a:tr h="347472">
+                <a:tc>
+                  <a:txBody>
+                    <a:bodyPr/>
+                    <a:lstStyle/>
+                    <a:p>
+                      <a:r>
+                        <a:rPr sz="1400" b="0">
+                          <a:solidFill>
+                            <a:srgbClr val="E9EFF5"/>
+                          </a:solidFill>
+                          <a:latin typeface="Helvetica Neue"/>
+                        </a:rPr>
+                        <a:t>Hand-off</a:t>
+                      </a:r>
+                    </a:p>
+                  </a:txBody>
+                  <a:tcPr>
+                    <a:solidFill>
+                      <a:srgbClr val="17202B"/>
+                    </a:solidFill>
+                  </a:tcPr>
+                </a:tc>
+                <a:tc>
+                  <a:txBody>
+                    <a:bodyPr/>
+                    <a:lstStyle/>
+                    <a:p>
+                      <a:r>
+                        <a:rPr sz="1400" b="0">
+                          <a:solidFill>
+                            <a:srgbClr val="E9EFF5"/>
+                          </a:solidFill>
+                          <a:latin typeface="Helvetica Neue"/>
+                        </a:rPr>
+                        <a:t>Copy plan as text (WhatsApp-ready) · print as a one-page wall sheet</a:t>
                       </a:r>
                     </a:p>
                   </a:txBody>
@@ -4868,7 +4914,7 @@
                 </a:solidFill>
                 <a:latin typeface="Helvetica Neue"/>
               </a:rPr>
-              <a:t>63/63 engine tests pass</a:t>
+              <a:t>69/69 engine tests pass</a:t>
             </a:r>
           </a:p>
           <a:p>

</xml_diff>

<commit_message>
deck: correct the walkthrough's stop-hour count and label the stop-work row's basis — same drift already fixed in SUBMISSION.md
</commit_message>
<xml_diff>
--- a/deck/ShramShield-HACKDAY-1.0.pptx
+++ b/deck/ShramShield-HACKDAY-1.0.pptx
@@ -4158,7 +4158,7 @@
                           </a:solidFill>
                           <a:latin typeface="Helvetica Neue"/>
                         </a:rPr>
-                        <a:t>11:00–14:00 for very heavy work on a real May 2025 Delhi day</a:t>
+                        <a:t>11:00–14:00 across the day, very heavy work, real May 2025 Delhi day</a:t>
                       </a:r>
                     </a:p>
                   </a:txBody>
@@ -5639,7 +5639,7 @@
                 </a:solidFill>
                 <a:latin typeface="Helvetica Neue"/>
               </a:rPr>
-              <a:t>2.  Dataset → Delhi heatwave (May 2025) and Work rate → Very heavy work: four hours that must stop, on a real 2025 day.</a:t>
+              <a:t>2.  Dataset → Delhi heatwave (May 2025) and Work rate → Very heavy work: the banner names the stop hours inside the shift, the timeline four across the day — a real 2025 day.</a:t>
             </a:r>
           </a:p>
           <a:p>

</xml_diff>

<commit_message>
feat: shared plan links unfurl with a title and description instead of a bare URL
The shareable plan URL is a headline feature and the plan text is written for WhatsApp, but the page carried no Open Graph tags. No image is declared rather than ship a placeholder.
</commit_message>
<xml_diff>
--- a/deck/ShramShield-HACKDAY-1.0.pptx
+++ b/deck/ShramShield-HACKDAY-1.0.pptx
@@ -5449,6 +5449,107 @@
           </a:p>
         </p:txBody>
       </p:sp>
+      <p:sp>
+        <p:nvSpPr>
+          <p:cNvPr id="10" name="Rectangle 9"/>
+          <p:cNvSpPr/>
+          <p:nvPr/>
+        </p:nvSpPr>
+        <p:spPr>
+          <a:xfrm>
+            <a:off x="6400800" y="5303520"/>
+            <a:ext cx="5212080" cy="1188720"/>
+          </a:xfrm>
+          <a:prstGeom prst="rect">
+            <a:avLst/>
+          </a:prstGeom>
+          <a:solidFill>
+            <a:srgbClr val="17202B"/>
+          </a:solidFill>
+          <a:ln>
+            <a:solidFill>
+              <a:srgbClr val="22303F"/>
+            </a:solidFill>
+          </a:ln>
+          <a:effectLst/>
+        </p:spPr>
+        <p:style>
+          <a:lnRef idx="1">
+            <a:schemeClr val="accent1"/>
+          </a:lnRef>
+          <a:fillRef idx="3">
+            <a:schemeClr val="accent1"/>
+          </a:fillRef>
+          <a:effectRef idx="2">
+            <a:schemeClr val="accent1"/>
+          </a:effectRef>
+          <a:fontRef idx="minor">
+            <a:schemeClr val="lt1"/>
+          </a:fontRef>
+        </p:style>
+        <p:txBody>
+          <a:bodyPr rtlCol="0" anchor="ctr"/>
+          <a:lstStyle/>
+          <a:p>
+            <a:pPr algn="ctr"/>
+          </a:p>
+        </p:txBody>
+      </p:sp>
+      <p:sp>
+        <p:nvSpPr>
+          <p:cNvPr id="11" name="TextBox 10"/>
+          <p:cNvSpPr txBox="1"/>
+          <p:nvPr/>
+        </p:nvSpPr>
+        <p:spPr>
+          <a:xfrm>
+            <a:off x="6675120" y="5440680"/>
+            <a:ext cx="4663440" cy="914400"/>
+          </a:xfrm>
+          <a:prstGeom prst="rect">
+            <a:avLst/>
+          </a:prstGeom>
+          <a:noFill/>
+        </p:spPr>
+        <p:txBody>
+          <a:bodyPr wrap="square">
+            <a:spAutoFit/>
+          </a:bodyPr>
+          <a:lstStyle/>
+          <a:p>
+            <a:pPr algn="l">
+              <a:spcAft>
+                <a:spcPts val="600"/>
+              </a:spcAft>
+            </a:pPr>
+            <a:r>
+              <a:rPr sz="1400" b="0">
+                <a:solidFill>
+                  <a:srgbClr val="E9EFF5"/>
+                </a:solidFill>
+                <a:latin typeface="Helvetica Neue"/>
+              </a:rPr>
+              <a:t>Cheap to run, measured</a:t>
+            </a:r>
+          </a:p>
+          <a:p>
+            <a:pPr algn="l">
+              <a:spcAft>
+                <a:spcPts val="600"/>
+              </a:spcAft>
+            </a:pPr>
+            <a:r>
+              <a:rPr sz="1400" b="0">
+                <a:solidFill>
+                  <a:srgbClr val="E9EFF5"/>
+                </a:solidFill>
+                <a:latin typeface="Helvetica Neue"/>
+              </a:rPr>
+              <a:t>95 KB in 3 requests, no server, no key, zero API calls unless a live forecast is asked for.</a:t>
+            </a:r>
+          </a:p>
+        </p:txBody>
+      </p:sp>
     </p:spTree>
   </p:cSld>
   <p:clrMapOvr>

</xml_diff>

<commit_message>
feat: the crew's hand-off sheet in Hindi, not just the supervisor's screen
Copy plan now produces the same plan in English or Hindi. Over 90% of India's outdoor workforce is informal; a stop-work instruction in a language the crew cannot read is not a safety control. English output is byte-identical, so the original tests still guard it, and a test asserts the Hindi sheet is never half-translated — a sheet that says STOP WORK in English is exactly the failure this prevents. 7 new tests.
</commit_message>
<xml_diff>
--- a/deck/ShramShield-HACKDAY-1.0.pptx
+++ b/deck/ShramShield-HACKDAY-1.0.pptx
@@ -4204,7 +4204,7 @@
                           </a:solidFill>
                           <a:latin typeface="Helvetica Neue"/>
                         </a:rPr>
-                        <a:t>Copy plan as text (WhatsApp-ready) · print as a one-page wall sheet</a:t>
+                        <a:t>Copy plan as text, English or Hindi (WhatsApp-ready) · print as a wall sheet</a:t>
                       </a:r>
                     </a:p>
                   </a:txBody>
@@ -4914,7 +4914,7 @@
                 </a:solidFill>
                 <a:latin typeface="Helvetica Neue"/>
               </a:rPr>
-              <a:t>76/76 engine tests pass</a:t>
+              <a:t>83/83 engine tests pass</a:t>
             </a:r>
           </a:p>
           <a:p>

</xml_diff>